<commit_message>
Update founder experience to 7+ years and 100+ projects
Co-Authored-By: Claude Sonnet 5.5 <noreply@anthropic.com>
Claude-Session: https://claude.ai/code/session_013DjCUcZXzThWAyFAMwdf3N
</commit_message>
<xml_diff>
--- a/VERDEAXIS_Company_Profile_v8.pptx
+++ b/VERDEAXIS_Company_Profile_v8.pptx
@@ -8288,7 +8288,7 @@
                   <a:schemeClr val="accent4"/>
                 </a:solidFill>
               </a:rPr>
-              <a:t>A new firm, led by someone who has done this work for 8+ years.</a:t>
+              <a:t>A new firm, led by someone who has delivered 100+ projects in 7+ years.</a:t>
             </a:r>
             <a:endParaRPr lang="en-US" sz="1400" dirty="0"/>
           </a:p>
@@ -8561,7 +8561,7 @@
                   <a:schemeClr val="accent5"/>
                 </a:solidFill>
               </a:rPr>
-              <a:t>8+</a:t>
+              <a:t>7+</a:t>
             </a:r>
             <a:endParaRPr lang="en-US" sz="3600" dirty="0"/>
           </a:p>
@@ -8660,7 +8660,7 @@
                   <a:schemeClr val="accent5"/>
                 </a:solidFill>
               </a:rPr>
-              <a:t>50+</a:t>
+              <a:t>100+</a:t>
             </a:r>
             <a:endParaRPr lang="en-US" sz="3600" dirty="0"/>
           </a:p>
@@ -8973,7 +8973,7 @@
                   <a:schemeClr val="tx1"/>
                 </a:solidFill>
               </a:rPr>
-              <a:t>Delivered certification, simulation and carbon projects across India, France, Vietnam, Cambodia and Thailand.</a:t>
+              <a:t>Has delivered 100+ certification, simulation and carbon projects across India, France, Vietnam, Cambodia and Thailand.</a:t>
             </a:r>
             <a:endParaRPr lang="en-US" sz="1400" dirty="0"/>
           </a:p>
@@ -9180,7 +9180,7 @@
                   <a:schemeClr val="accent4"/>
                 </a:solidFill>
               </a:rPr>
-              <a:t>Selected projects delivered by our founder before forming the firm.</a:t>
+              <a:t>A selection from the founder's 100+ projects, delivered before forming the firm.</a:t>
             </a:r>
             <a:endParaRPr lang="en-US" sz="1400" dirty="0"/>
           </a:p>

</xml_diff>